<commit_message>
Reemplazar matriz de correlación por boxplot de outliers en slide 2
</commit_message>
<xml_diff>
--- a/TP_Grupal_slides.pptx
+++ b/TP_Grupal_slides.pptx
@@ -4190,7 +4190,7 @@
       </p:pic>
       <p:pic>
         <p:nvPicPr>
-          <p:cNvPr id="8" name="Picture 7" descr="corr.png"/>
+          <p:cNvPr id="8" name="Picture 7" descr="box.png"/>
           <p:cNvPicPr>
             <a:picLocks noChangeAspect="1"/>
           </p:cNvPicPr>
@@ -4205,7 +4205,7 @@
         <p:spPr>
           <a:xfrm>
             <a:off x="6355080" y="4206240"/>
-            <a:ext cx="5303520" cy="4397008"/>
+            <a:ext cx="5303520" cy="3612752"/>
           </a:xfrm>
           <a:prstGeom prst="rect">
             <a:avLst/>

</xml_diff>